<commit_message>
Replace project with paper.
</commit_message>
<xml_diff>
--- a/Prezentare_Atestat_Mondea_George.pptx
+++ b/Prezentare_Atestat_Mondea_George.pptx
@@ -7494,10 +7494,10 @@
       </p:grpSpPr>
       <p:pic>
         <p:nvPicPr>
-          <p:cNvPr id="2" name="Picture 1">
+          <p:cNvPr id="3" name="Picture 2">
             <a:extLst>
               <a:ext uri="{FF2B5EF4-FFF2-40B4-BE49-F238E27FC236}">
-                <a16:creationId xmlns:a16="http://schemas.microsoft.com/office/drawing/2014/main" id="{3E3F7F92-6B8D-CCAA-248F-469FCA1614C8}"/>
+                <a16:creationId xmlns:a16="http://schemas.microsoft.com/office/drawing/2014/main" id="{965D7B16-9368-A88F-921E-828366CB3939}"/>
               </a:ext>
             </a:extLst>
           </p:cNvPr>
@@ -7514,8 +7514,8 @@
         </p:blipFill>
         <p:spPr>
           <a:xfrm>
-            <a:off x="1" y="0"/>
-            <a:ext cx="9143998" cy="5143499"/>
+            <a:off x="0" y="-1"/>
+            <a:ext cx="9144000" cy="5143501"/>
           </a:xfrm>
           <a:prstGeom prst="rect">
             <a:avLst/>

</xml_diff>